<commit_message>
Rebuild deck so .pptx artifact reflects 404 Team Not Found branding
</commit_message>
<xml_diff>
--- a/presentation/Phase4_presentation.pptx
+++ b/presentation/Phase4_presentation.pptx
@@ -3289,7 +3289,42 @@
         </p:nvSpPr>
         <p:spPr>
           <a:xfrm>
-            <a:off x="822960" y="5852160"/>
+            <a:off x="822960" y="5669280"/>
+            <a:ext cx="10972800" cy="320040"/>
+          </a:xfrm>
+          <a:prstGeom prst="rect">
+            <a:avLst/>
+          </a:prstGeom>
+          <a:noFill/>
+        </p:spPr>
+        <p:txBody>
+          <a:bodyPr wrap="square" lIns="0" rIns="0" tIns="0" bIns="0" anchor="t">
+            <a:spAutoFit/>
+          </a:bodyPr>
+          <a:lstStyle/>
+          <a:p>
+            <a:pPr algn="l"/>
+            <a:r>
+              <a:rPr sz="1300" b="1" i="0">
+                <a:solidFill>
+                  <a:srgbClr val="E89E2C"/>
+                </a:solidFill>
+                <a:latin typeface="Calibri"/>
+              </a:rPr>
+              <a:t>Team  -  404 Team Not Found</a:t>
+            </a:r>
+          </a:p>
+        </p:txBody>
+      </p:sp>
+      <p:sp>
+        <p:nvSpPr>
+          <p:cNvPr id="7" name="TextBox 6"/>
+          <p:cNvSpPr txBox="1"/>
+          <p:nvPr/>
+        </p:nvSpPr>
+        <p:spPr>
+          <a:xfrm>
+            <a:off x="822960" y="5989320"/>
             <a:ext cx="10972800" cy="365760"/>
           </a:xfrm>
           <a:prstGeom prst="rect">
@@ -3311,14 +3346,14 @@
                 </a:solidFill>
                 <a:latin typeface="Calibri"/>
               </a:rPr>
-              <a:t>Team  -  Aayush Nepal  |  Junwei Zhang  |  Lusi Zhang</a:t>
-            </a:r>
-          </a:p>
-        </p:txBody>
-      </p:sp>
-      <p:sp>
-        <p:nvSpPr>
-          <p:cNvPr id="7" name="TextBox 6"/>
+              <a:t>Aayush Nepal  |  Junwei Zhang  |  Lusi Zhang</a:t>
+            </a:r>
+          </a:p>
+        </p:txBody>
+      </p:sp>
+      <p:sp>
+        <p:nvSpPr>
+          <p:cNvPr id="8" name="TextBox 7"/>
           <p:cNvSpPr txBox="1"/>
           <p:nvPr/>
         </p:nvSpPr>
@@ -6261,7 +6296,42 @@
       </p:sp>
       <p:sp>
         <p:nvSpPr>
-          <p:cNvPr id="5" name="Rounded Rectangle 4"/>
+          <p:cNvPr id="5" name="TextBox 4"/>
+          <p:cNvSpPr txBox="1"/>
+          <p:nvPr/>
+        </p:nvSpPr>
+        <p:spPr>
+          <a:xfrm>
+            <a:off x="822960" y="3383280"/>
+            <a:ext cx="10972800" cy="365760"/>
+          </a:xfrm>
+          <a:prstGeom prst="rect">
+            <a:avLst/>
+          </a:prstGeom>
+          <a:noFill/>
+        </p:spPr>
+        <p:txBody>
+          <a:bodyPr wrap="square" lIns="0" rIns="0" tIns="0" bIns="0" anchor="t">
+            <a:spAutoFit/>
+          </a:bodyPr>
+          <a:lstStyle/>
+          <a:p>
+            <a:pPr algn="l"/>
+            <a:r>
+              <a:rPr sz="1300" b="0" i="1">
+                <a:solidFill>
+                  <a:srgbClr val="FFFFFF"/>
+                </a:solidFill>
+                <a:latin typeface="Calibri"/>
+              </a:rPr>
+              <a:t>404 Team Not Found  -  Aayush Nepal | Junwei Zhang | Lusi Zhang</a:t>
+            </a:r>
+          </a:p>
+        </p:txBody>
+      </p:sp>
+      <p:sp>
+        <p:nvSpPr>
+          <p:cNvPr id="6" name="Rounded Rectangle 5"/>
           <p:cNvSpPr/>
           <p:nvPr/>
         </p:nvSpPr>
@@ -6307,7 +6377,7 @@
       </p:sp>
       <p:sp>
         <p:nvSpPr>
-          <p:cNvPr id="6" name="TextBox 5"/>
+          <p:cNvPr id="7" name="TextBox 6"/>
           <p:cNvSpPr txBox="1"/>
           <p:nvPr/>
         </p:nvSpPr>
@@ -6342,7 +6412,7 @@
       </p:sp>
       <p:sp>
         <p:nvSpPr>
-          <p:cNvPr id="7" name="TextBox 6"/>
+          <p:cNvPr id="8" name="TextBox 7"/>
           <p:cNvSpPr txBox="1"/>
           <p:nvPr/>
         </p:nvSpPr>
@@ -6377,7 +6447,7 @@
       </p:sp>
       <p:sp>
         <p:nvSpPr>
-          <p:cNvPr id="8" name="Rounded Rectangle 7"/>
+          <p:cNvPr id="9" name="Rounded Rectangle 8"/>
           <p:cNvSpPr/>
           <p:nvPr/>
         </p:nvSpPr>
@@ -6423,7 +6493,7 @@
       </p:sp>
       <p:sp>
         <p:nvSpPr>
-          <p:cNvPr id="9" name="TextBox 8"/>
+          <p:cNvPr id="10" name="TextBox 9"/>
           <p:cNvSpPr txBox="1"/>
           <p:nvPr/>
         </p:nvSpPr>
@@ -6458,7 +6528,7 @@
       </p:sp>
       <p:sp>
         <p:nvSpPr>
-          <p:cNvPr id="10" name="TextBox 9"/>
+          <p:cNvPr id="11" name="TextBox 10"/>
           <p:cNvSpPr txBox="1"/>
           <p:nvPr/>
         </p:nvSpPr>
@@ -6493,7 +6563,7 @@
       </p:sp>
       <p:sp>
         <p:nvSpPr>
-          <p:cNvPr id="11" name="Rounded Rectangle 10"/>
+          <p:cNvPr id="12" name="Rounded Rectangle 11"/>
           <p:cNvSpPr/>
           <p:nvPr/>
         </p:nvSpPr>
@@ -6539,7 +6609,7 @@
       </p:sp>
       <p:sp>
         <p:nvSpPr>
-          <p:cNvPr id="12" name="TextBox 11"/>
+          <p:cNvPr id="13" name="TextBox 12"/>
           <p:cNvSpPr txBox="1"/>
           <p:nvPr/>
         </p:nvSpPr>
@@ -6574,7 +6644,7 @@
       </p:sp>
       <p:sp>
         <p:nvSpPr>
-          <p:cNvPr id="13" name="TextBox 12"/>
+          <p:cNvPr id="14" name="TextBox 13"/>
           <p:cNvSpPr txBox="1"/>
           <p:nvPr/>
         </p:nvSpPr>
@@ -6609,7 +6679,7 @@
       </p:sp>
       <p:sp>
         <p:nvSpPr>
-          <p:cNvPr id="14" name="TextBox 13"/>
+          <p:cNvPr id="15" name="TextBox 14"/>
           <p:cNvSpPr txBox="1"/>
           <p:nvPr/>
         </p:nvSpPr>

</xml_diff>